<commit_message>
Work in progress across the workspace
Everything that was outstanding in the working tree at 2026-09-24 20:00, in one
commit so the branches stay comparable: the IDS 2026 country packs and dealer
compare pages, the distributor one-pagers, the ITUK dealer master and dealer
demand model, the IMotors handover renders, the scraper Phase 0 results, the UIO
V20 candidate notes, the warranty and tonnage work from earlier in the day, and
the shared state packet and delegator board rows that record all of it.

Co-authored-by: Cursor <cursoragent@cursor.com>
</commit_message>
<xml_diff>
--- a/Isuzu Universe/ISUZU_UNIVERSE_3_0_DECK_2026-09-23.pptx
+++ b/Isuzu Universe/ISUZU_UNIVERSE_3_0_DECK_2026-09-23.pptx
@@ -875,7 +875,7 @@
           <a:lstStyle/>
           <a:p>
             <a:r>
-              <a:t>334 of the 519 dealers in our network file already carry a recorded IDS score, minimum zero, maximum 100, average 77.5. That is two-thirds of the known estate with an individual result already on file, and it is the only place in this programme where ISZE holds something a dealer will want to look at and cannot easily assemble itself. So the IDS profile should be the opening offer, not a later step. Right now the design brings a review to the dealer first, which reads as a supplier's opinion of its business.</a:t>
+              <a:t>490 of the 519 dealers in our network file carry a recorded Dealer Standards score, minimum above zero, maximum 100, average 79.3. A further 29 recorded no answers at all and are held apart from the distribution, because no score exists for them. That is almost all of the known already on file, and it is the only place in this programme where ISZE holds something a dealer will want to look at and cannot easily assemble itself. So the IDS profile should be the opening offer, not a later step. Right now the design brings a review to the dealer first, which reads as a supplier's opinion of its business.</a:t>
             </a:r>
           </a:p>
         </p:txBody>
@@ -7182,8 +7182,8 @@
         </p:blipFill>
         <p:spPr>
           <a:xfrm>
-            <a:off x="1424691" y="1783080"/>
-            <a:ext cx="9342311" cy="4160520"/>
+            <a:off x="1018504" y="1783080"/>
+            <a:ext cx="10154686" cy="4160520"/>
           </a:xfrm>
           <a:prstGeom prst="rect">
             <a:avLst/>

</xml_diff>